<commit_message>
README link + academic-style notebook and presentation
</commit_message>
<xml_diff>
--- a/presentation/presentation.pptx
+++ b/presentation/presentation.pptx
@@ -11,6 +11,7 @@
     <p:sldId id="259" r:id="rId10"/>
     <p:sldId id="260" r:id="rId11"/>
     <p:sldId id="261" r:id="rId12"/>
+    <p:sldId id="262" r:id="rId13"/>
   </p:sldIdLst>
   <p:sldSz cx="12191695" cy="6858000" type="screen4x3"/>
   <p:notesSz cx="6858000" cy="9144000"/>
@@ -3101,8 +3102,8 @@
         </p:nvSpPr>
         <p:spPr>
           <a:xfrm>
-            <a:off x="640080" y="2011680"/>
-            <a:ext cx="10972800" cy="2286000"/>
+            <a:off x="640080" y="1828800"/>
+            <a:ext cx="10972800" cy="1188720"/>
           </a:xfrm>
           <a:prstGeom prst="rect">
             <a:avLst/>
@@ -3110,29 +3111,94 @@
           <a:noFill/>
         </p:spPr>
         <p:txBody>
+          <a:bodyPr wrap="none">
+            <a:spAutoFit/>
+          </a:bodyPr>
+          <a:lstStyle/>
+          <a:p>
+            <a:r>
+              <a:rPr sz="4400" b="1">
+                <a:solidFill>
+                  <a:srgbClr val="1F2D5A"/>
+                </a:solidFill>
+              </a:rPr>
+              <a:t>Автоматизация ML-пайплайна</a:t>
+            </a:r>
+          </a:p>
+        </p:txBody>
+      </p:sp>
+      <p:sp>
+        <p:nvSpPr>
+          <p:cNvPr id="3" name="TextBox 2"/>
+          <p:cNvSpPr txBox="1"/>
+          <p:nvPr/>
+        </p:nvSpPr>
+        <p:spPr>
+          <a:xfrm>
+            <a:off x="640080" y="3017520"/>
+            <a:ext cx="10972800" cy="731520"/>
+          </a:xfrm>
+          <a:prstGeom prst="rect">
+            <a:avLst/>
+          </a:prstGeom>
+          <a:noFill/>
+        </p:spPr>
+        <p:txBody>
+          <a:bodyPr wrap="none">
+            <a:spAutoFit/>
+          </a:bodyPr>
+          <a:lstStyle/>
+          <a:p>
+            <a:r>
+              <a:rPr sz="2400">
+                <a:solidFill>
+                  <a:srgbClr val="4C72B0"/>
+                </a:solidFill>
+              </a:rPr>
+              <a:t>Knowledge tracing на датасете ASSISTments 2009</a:t>
+            </a:r>
+          </a:p>
+        </p:txBody>
+      </p:sp>
+      <p:sp>
+        <p:nvSpPr>
+          <p:cNvPr id="4" name="TextBox 3"/>
+          <p:cNvSpPr txBox="1"/>
+          <p:nvPr/>
+        </p:nvSpPr>
+        <p:spPr>
+          <a:xfrm>
+            <a:off x="640080" y="5029200"/>
+            <a:ext cx="10972800" cy="1371600"/>
+          </a:xfrm>
+          <a:prstGeom prst="rect">
+            <a:avLst/>
+          </a:prstGeom>
+          <a:noFill/>
+        </p:spPr>
+        <p:txBody>
           <a:bodyPr wrap="square">
             <a:spAutoFit/>
           </a:bodyPr>
           <a:lstStyle/>
           <a:p>
             <a:r>
-              <a:rPr sz="4400" b="1">
-                <a:solidFill>
-                  <a:srgbClr val="1F2D5A"/>
-                </a:solidFill>
-              </a:rPr>
-              <a:t>Автоматизация ML-пайплайна</a:t>
-            </a:r>
-          </a:p>
-          <a:p>
-            <a:r>
-              <a:rPr sz="2200">
+              <a:rPr sz="1800">
                 <a:solidFill>
                   <a:srgbClr val="555555"/>
                 </a:solidFill>
               </a:rPr>
-              <a:t>Knowledge Tracing на датасете ASSISTments 2009
-BKT · DKT+Optuna · AutoML (FLAML)</a:t>
+              <a:t>Автор: Григорьева Е.С.</a:t>
+            </a:r>
+          </a:p>
+          <a:p>
+            <a:r>
+              <a:rPr sz="1800">
+                <a:solidFill>
+                  <a:srgbClr val="555555"/>
+                </a:solidFill>
+              </a:rPr>
+              <a:t>Май 2026</a:t>
             </a:r>
           </a:p>
         </p:txBody>
@@ -3163,8 +3229,8 @@
         </p:nvSpPr>
         <p:spPr>
           <a:xfrm>
-            <a:off x="548640" y="365760"/>
-            <a:ext cx="10972800" cy="914400"/>
+            <a:off x="548640" y="320040"/>
+            <a:ext cx="11064240" cy="822960"/>
           </a:xfrm>
           <a:prstGeom prst="rect">
             <a:avLst/>
@@ -3178,12 +3244,12 @@
           <a:lstStyle/>
           <a:p>
             <a:r>
-              <a:rPr sz="3200" b="1">
+              <a:rPr sz="3000" b="1">
                 <a:solidFill>
                   <a:srgbClr val="1F2D5A"/>
                 </a:solidFill>
               </a:rPr>
-              <a:t>Бизнес-задача</a:t>
+              <a:t>Постановка задачи</a:t>
             </a:r>
           </a:p>
         </p:txBody>
@@ -3196,8 +3262,8 @@
         </p:nvSpPr>
         <p:spPr>
           <a:xfrm>
-            <a:off x="640080" y="1371600"/>
-            <a:ext cx="10972800" cy="5029200"/>
+            <a:off x="548640" y="1188720"/>
+            <a:ext cx="11064240" cy="914400"/>
           </a:xfrm>
           <a:prstGeom prst="rect">
             <a:avLst/>
@@ -3212,56 +3278,250 @@
           <a:p>
             <a:pPr>
               <a:spcAft>
-                <a:spcPts val="800"/>
-              </a:spcAft>
-            </a:pPr>
-            <a:r>
-              <a:rPr sz="1800"/>
-              <a:t>•  Ключевой вопрос: ответит ли студент верно на следующую задачу по навыку?</a:t>
-            </a:r>
-          </a:p>
-          <a:p>
-            <a:pPr>
-              <a:spcAft>
-                <a:spcPts val="800"/>
-              </a:spcAft>
-            </a:pPr>
-            <a:r>
-              <a:rPr sz="1800"/>
-              <a:t>•  Зачем: точный прогноз знаний → адаптивные рекомендации (что учить, что повторить).</a:t>
-            </a:r>
-          </a:p>
-          <a:p>
-            <a:pPr>
-              <a:spcAft>
-                <a:spcPts val="800"/>
-              </a:spcAft>
-            </a:pPr>
-            <a:r>
-              <a:rPr sz="1800"/>
-              <a:t>•  Эффект: меньше отвала и фрустрации, выше завершаемость курса.</a:t>
-            </a:r>
-          </a:p>
-          <a:p>
-            <a:pPr>
-              <a:spcAft>
-                <a:spcPts val="800"/>
-              </a:spcAft>
-            </a:pPr>
-            <a:r>
-              <a:rPr sz="1800"/>
-              <a:t>•  Тип задачи: бинарная классификация на временных рядах (knowledge tracing).</a:t>
-            </a:r>
-          </a:p>
-          <a:p>
-            <a:pPr>
-              <a:spcAft>
-                <a:spcPts val="800"/>
-              </a:spcAft>
-            </a:pPr>
-            <a:r>
-              <a:rPr sz="1800"/>
-              <a:t>•  Метрика успеха: ROC-AUC прогноза следующего ответа.</a:t>
+                <a:spcPts val="600"/>
+              </a:spcAft>
+            </a:pPr>
+            <a:r>
+              <a:rPr sz="1700" b="1">
+                <a:solidFill>
+                  <a:srgbClr val="1F2D5A"/>
+                </a:solidFill>
+              </a:rPr>
+              <a:t>Предметная область</a:t>
+            </a:r>
+          </a:p>
+        </p:txBody>
+      </p:sp>
+      <p:sp>
+        <p:nvSpPr>
+          <p:cNvPr id="4" name="TextBox 3"/>
+          <p:cNvSpPr txBox="1"/>
+          <p:nvPr/>
+        </p:nvSpPr>
+        <p:spPr>
+          <a:xfrm>
+            <a:off x="548640" y="1554480"/>
+            <a:ext cx="11064240" cy="1280160"/>
+          </a:xfrm>
+          <a:prstGeom prst="rect">
+            <a:avLst/>
+          </a:prstGeom>
+          <a:noFill/>
+        </p:spPr>
+        <p:txBody>
+          <a:bodyPr wrap="square">
+            <a:spAutoFit/>
+          </a:bodyPr>
+          <a:lstStyle/>
+          <a:p>
+            <a:pPr>
+              <a:spcAft>
+                <a:spcPts val="600"/>
+              </a:spcAft>
+            </a:pPr>
+            <a:r>
+              <a:rPr sz="1500" b="0">
+                <a:solidFill>
+                  <a:srgbClr val="222222"/>
+                </a:solidFill>
+              </a:rPr>
+              <a:t>Knowledge tracing — задача образовательной аналитики: по истории</a:t>
+            </a:r>
+          </a:p>
+          <a:p>
+            <a:pPr>
+              <a:spcAft>
+                <a:spcPts val="600"/>
+              </a:spcAft>
+            </a:pPr>
+            <a:r>
+              <a:rPr sz="1500" b="0">
+                <a:solidFill>
+                  <a:srgbClr val="222222"/>
+                </a:solidFill>
+              </a:rPr>
+              <a:t>взаимодействий студента (тройки «студент, навык, верно/неверно»),</a:t>
+            </a:r>
+          </a:p>
+          <a:p>
+            <a:pPr>
+              <a:spcAft>
+                <a:spcPts val="600"/>
+              </a:spcAft>
+            </a:pPr>
+            <a:r>
+              <a:rPr sz="1500" b="0">
+                <a:solidFill>
+                  <a:srgbClr val="222222"/>
+                </a:solidFill>
+              </a:rPr>
+              <a:t>упорядоченных по времени, оценить уровень владения каждым навыком</a:t>
+            </a:r>
+          </a:p>
+          <a:p>
+            <a:pPr>
+              <a:spcAft>
+                <a:spcPts val="600"/>
+              </a:spcAft>
+            </a:pPr>
+            <a:r>
+              <a:rPr sz="1500" b="0">
+                <a:solidFill>
+                  <a:srgbClr val="222222"/>
+                </a:solidFill>
+              </a:rPr>
+              <a:t>и предсказать результат следующего ответа (one-step-ahead).</a:t>
+            </a:r>
+          </a:p>
+        </p:txBody>
+      </p:sp>
+      <p:sp>
+        <p:nvSpPr>
+          <p:cNvPr id="5" name="TextBox 4"/>
+          <p:cNvSpPr txBox="1"/>
+          <p:nvPr/>
+        </p:nvSpPr>
+        <p:spPr>
+          <a:xfrm>
+            <a:off x="548640" y="3200400"/>
+            <a:ext cx="11064240" cy="457200"/>
+          </a:xfrm>
+          <a:prstGeom prst="rect">
+            <a:avLst/>
+          </a:prstGeom>
+          <a:noFill/>
+        </p:spPr>
+        <p:txBody>
+          <a:bodyPr wrap="square">
+            <a:spAutoFit/>
+          </a:bodyPr>
+          <a:lstStyle/>
+          <a:p>
+            <a:pPr>
+              <a:spcAft>
+                <a:spcPts val="600"/>
+              </a:spcAft>
+            </a:pPr>
+            <a:r>
+              <a:rPr sz="1700" b="1">
+                <a:solidFill>
+                  <a:srgbClr val="1F2D5A"/>
+                </a:solidFill>
+              </a:rPr>
+              <a:t>Формализация ML-задачи</a:t>
+            </a:r>
+          </a:p>
+        </p:txBody>
+      </p:sp>
+      <p:sp>
+        <p:nvSpPr>
+          <p:cNvPr id="6" name="TextBox 5"/>
+          <p:cNvSpPr txBox="1"/>
+          <p:nvPr/>
+        </p:nvSpPr>
+        <p:spPr>
+          <a:xfrm>
+            <a:off x="548640" y="3657600"/>
+            <a:ext cx="11064240" cy="2468880"/>
+          </a:xfrm>
+          <a:prstGeom prst="rect">
+            <a:avLst/>
+          </a:prstGeom>
+          <a:noFill/>
+        </p:spPr>
+        <p:txBody>
+          <a:bodyPr wrap="square">
+            <a:spAutoFit/>
+          </a:bodyPr>
+          <a:lstStyle/>
+          <a:p>
+            <a:pPr>
+              <a:spcAft>
+                <a:spcPts val="600"/>
+              </a:spcAft>
+            </a:pPr>
+            <a:r>
+              <a:rPr sz="1500">
+                <a:solidFill>
+                  <a:srgbClr val="222222"/>
+                </a:solidFill>
+              </a:rPr>
+              <a:t>•  Тип: бинарная классификация на временных рядах (correct ∈ {0, 1}).</a:t>
+            </a:r>
+          </a:p>
+          <a:p>
+            <a:pPr>
+              <a:spcAft>
+                <a:spcPts val="600"/>
+              </a:spcAft>
+            </a:pPr>
+            <a:r>
+              <a:rPr sz="1500">
+                <a:solidFill>
+                  <a:srgbClr val="222222"/>
+                </a:solidFill>
+              </a:rPr>
+              <a:t>•  Вход: история до момента t — последовательность (skill_id, correct) или табличные причинные признаки.</a:t>
+            </a:r>
+          </a:p>
+          <a:p>
+            <a:pPr>
+              <a:spcAft>
+                <a:spcPts val="600"/>
+              </a:spcAft>
+            </a:pPr>
+            <a:r>
+              <a:rPr sz="1500">
+                <a:solidFill>
+                  <a:srgbClr val="222222"/>
+                </a:solidFill>
+              </a:rPr>
+              <a:t>•  Выход: вероятность правильного ответа на шаге t + 1.</a:t>
+            </a:r>
+          </a:p>
+          <a:p>
+            <a:pPr>
+              <a:spcAft>
+                <a:spcPts val="600"/>
+              </a:spcAft>
+            </a:pPr>
+            <a:r>
+              <a:rPr sz="1500">
+                <a:solidFill>
+                  <a:srgbClr val="222222"/>
+                </a:solidFill>
+              </a:rPr>
+              <a:t>•  Основная метрика: ROC-AUC (устойчива к несбалансированности классов).</a:t>
+            </a:r>
+          </a:p>
+          <a:p>
+            <a:pPr>
+              <a:spcAft>
+                <a:spcPts val="600"/>
+              </a:spcAft>
+            </a:pPr>
+            <a:r>
+              <a:rPr sz="1500">
+                <a:solidFill>
+                  <a:srgbClr val="222222"/>
+                </a:solidFill>
+              </a:rPr>
+              <a:t>•  Дополнительно: Accuracy, F1, Precision, Recall, RMSE, log-loss.</a:t>
+            </a:r>
+          </a:p>
+          <a:p>
+            <a:pPr>
+              <a:spcAft>
+                <a:spcPts val="600"/>
+              </a:spcAft>
+            </a:pPr>
+            <a:r>
+              <a:rPr sz="1500">
+                <a:solidFill>
+                  <a:srgbClr val="222222"/>
+                </a:solidFill>
+              </a:rPr>
+              <a:t>•  Сплит выборки выполняется по студентам, что исключает утечку между train, val и test.</a:t>
             </a:r>
           </a:p>
         </p:txBody>
@@ -3292,8 +3552,8 @@
         </p:nvSpPr>
         <p:spPr>
           <a:xfrm>
-            <a:off x="548640" y="365760"/>
-            <a:ext cx="10972800" cy="914400"/>
+            <a:off x="548640" y="320040"/>
+            <a:ext cx="11064240" cy="822960"/>
           </a:xfrm>
           <a:prstGeom prst="rect">
             <a:avLst/>
@@ -3307,7 +3567,7 @@
           <a:lstStyle/>
           <a:p>
             <a:r>
-              <a:rPr sz="3200" b="1">
+              <a:rPr sz="3000" b="1">
                 <a:solidFill>
                   <a:srgbClr val="1F2D5A"/>
                 </a:solidFill>
@@ -3325,8 +3585,8 @@
         </p:nvSpPr>
         <p:spPr>
           <a:xfrm>
-            <a:off x="640080" y="1371600"/>
-            <a:ext cx="5669280" cy="5029200"/>
+            <a:off x="548640" y="1188720"/>
+            <a:ext cx="5852160" cy="457200"/>
           </a:xfrm>
           <a:prstGeom prst="rect">
             <a:avLst/>
@@ -3341,74 +3601,242 @@
           <a:p>
             <a:pPr>
               <a:spcAft>
-                <a:spcPts val="800"/>
-              </a:spcAft>
-            </a:pPr>
-            <a:r>
-              <a:rPr sz="1800"/>
-              <a:t>•  Датасет: публичный ASSISTments 2009 (skill-builder) — стандартный бенчмарк KT.</a:t>
-            </a:r>
-          </a:p>
-          <a:p>
-            <a:pPr>
-              <a:spcAft>
-                <a:spcPts val="800"/>
-              </a:spcAft>
-            </a:pPr>
-            <a:r>
-              <a:rPr sz="1800"/>
-              <a:t>•  Объём: 3862 студентов, 215673 взаимодействий, 109 навыков.</a:t>
-            </a:r>
-          </a:p>
-          <a:p>
-            <a:pPr>
-              <a:spcAft>
-                <a:spcPts val="800"/>
-              </a:spcAft>
-            </a:pPr>
-            <a:r>
-              <a:rPr sz="1800"/>
-              <a:t>•  Сырьё: (студент, навык, верно/неверно) в хронологическом порядке.</a:t>
-            </a:r>
-          </a:p>
-          <a:p>
-            <a:pPr>
-              <a:spcAft>
-                <a:spcPts val="800"/>
-              </a:spcAft>
-            </a:pPr>
-            <a:r>
-              <a:rPr sz="1800"/>
-              <a:t>•  Причинные признаки: прошлая доля верных у студента и по навыку,</a:t>
-            </a:r>
-          </a:p>
-          <a:p>
-            <a:pPr>
-              <a:spcAft>
-                <a:spcPts val="800"/>
-              </a:spcAft>
-            </a:pPr>
-            <a:r>
-              <a:rPr sz="1800"/>
-              <a:t>•  номер попытки, сложность навыка, скользящая успешность за 3 шага.</a:t>
-            </a:r>
-          </a:p>
-          <a:p>
-            <a:pPr>
-              <a:spcAft>
-                <a:spcPts val="800"/>
-              </a:spcAft>
-            </a:pPr>
-            <a:r>
-              <a:rPr sz="1800"/>
-              <a:t>•  Сплит по студентам (без утечки между train/val/test).</a:t>
+                <a:spcPts val="600"/>
+              </a:spcAft>
+            </a:pPr>
+            <a:r>
+              <a:rPr sz="1700" b="1">
+                <a:solidFill>
+                  <a:srgbClr val="1F2D5A"/>
+                </a:solidFill>
+              </a:rPr>
+              <a:t>Датасет ASSISTments 2009 (skill-builder)</a:t>
+            </a:r>
+          </a:p>
+        </p:txBody>
+      </p:sp>
+      <p:sp>
+        <p:nvSpPr>
+          <p:cNvPr id="4" name="TextBox 3"/>
+          <p:cNvSpPr txBox="1"/>
+          <p:nvPr/>
+        </p:nvSpPr>
+        <p:spPr>
+          <a:xfrm>
+            <a:off x="548640" y="1691640"/>
+            <a:ext cx="5852160" cy="2103120"/>
+          </a:xfrm>
+          <a:prstGeom prst="rect">
+            <a:avLst/>
+          </a:prstGeom>
+          <a:noFill/>
+        </p:spPr>
+        <p:txBody>
+          <a:bodyPr wrap="square">
+            <a:spAutoFit/>
+          </a:bodyPr>
+          <a:lstStyle/>
+          <a:p>
+            <a:pPr>
+              <a:spcAft>
+                <a:spcPts val="600"/>
+              </a:spcAft>
+            </a:pPr>
+            <a:r>
+              <a:rPr sz="1400">
+                <a:solidFill>
+                  <a:srgbClr val="222222"/>
+                </a:solidFill>
+              </a:rPr>
+              <a:t>•  3862 студентов · 215673 взаимодействий · 109 навыков.</a:t>
+            </a:r>
+          </a:p>
+          <a:p>
+            <a:pPr>
+              <a:spcAft>
+                <a:spcPts val="600"/>
+              </a:spcAft>
+            </a:pPr>
+            <a:r>
+              <a:rPr sz="1400">
+                <a:solidFill>
+                  <a:srgbClr val="222222"/>
+                </a:solidFill>
+              </a:rPr>
+              <a:t>•  Глобальная доля верных ответов: 0.6351.</a:t>
+            </a:r>
+          </a:p>
+          <a:p>
+            <a:pPr>
+              <a:spcAft>
+                <a:spcPts val="600"/>
+              </a:spcAft>
+            </a:pPr>
+            <a:r>
+              <a:rPr sz="1400">
+                <a:solidFill>
+                  <a:srgbClr val="222222"/>
+                </a:solidFill>
+              </a:rPr>
+              <a:t>•  Сплит по студентам 70/10/20: train 2704, val 386, test 772.</a:t>
+            </a:r>
+          </a:p>
+          <a:p>
+            <a:pPr>
+              <a:spcAft>
+                <a:spcPts val="600"/>
+              </a:spcAft>
+            </a:pPr>
+            <a:r>
+              <a:rPr sz="1400">
+                <a:solidFill>
+                  <a:srgbClr val="222222"/>
+                </a:solidFill>
+              </a:rPr>
+              <a:t>•  Закоммичен sample на 288 студентов для офлайн-тестов и CI.</a:t>
+            </a:r>
+          </a:p>
+        </p:txBody>
+      </p:sp>
+      <p:sp>
+        <p:nvSpPr>
+          <p:cNvPr id="5" name="TextBox 4"/>
+          <p:cNvSpPr txBox="1"/>
+          <p:nvPr/>
+        </p:nvSpPr>
+        <p:spPr>
+          <a:xfrm>
+            <a:off x="548640" y="3840480"/>
+            <a:ext cx="5852160" cy="457200"/>
+          </a:xfrm>
+          <a:prstGeom prst="rect">
+            <a:avLst/>
+          </a:prstGeom>
+          <a:noFill/>
+        </p:spPr>
+        <p:txBody>
+          <a:bodyPr wrap="square">
+            <a:spAutoFit/>
+          </a:bodyPr>
+          <a:lstStyle/>
+          <a:p>
+            <a:pPr>
+              <a:spcAft>
+                <a:spcPts val="600"/>
+              </a:spcAft>
+            </a:pPr>
+            <a:r>
+              <a:rPr sz="1700" b="1">
+                <a:solidFill>
+                  <a:srgbClr val="1F2D5A"/>
+                </a:solidFill>
+              </a:rPr>
+              <a:t>Восемь причинных признаков</a:t>
+            </a:r>
+          </a:p>
+        </p:txBody>
+      </p:sp>
+      <p:sp>
+        <p:nvSpPr>
+          <p:cNvPr id="6" name="TextBox 5"/>
+          <p:cNvSpPr txBox="1"/>
+          <p:nvPr/>
+        </p:nvSpPr>
+        <p:spPr>
+          <a:xfrm>
+            <a:off x="548640" y="4343400"/>
+            <a:ext cx="5852160" cy="2286000"/>
+          </a:xfrm>
+          <a:prstGeom prst="rect">
+            <a:avLst/>
+          </a:prstGeom>
+          <a:noFill/>
+        </p:spPr>
+        <p:txBody>
+          <a:bodyPr wrap="square">
+            <a:spAutoFit/>
+          </a:bodyPr>
+          <a:lstStyle/>
+          <a:p>
+            <a:pPr>
+              <a:spcAft>
+                <a:spcPts val="600"/>
+              </a:spcAft>
+            </a:pPr>
+            <a:r>
+              <a:rPr sz="1300">
+                <a:solidFill>
+                  <a:srgbClr val="222222"/>
+                </a:solidFill>
+              </a:rPr>
+              <a:t>•  skill_idx, order_idx — кто и когда.</a:t>
+            </a:r>
+          </a:p>
+          <a:p>
+            <a:pPr>
+              <a:spcAft>
+                <a:spcPts val="600"/>
+              </a:spcAft>
+            </a:pPr>
+            <a:r>
+              <a:rPr sz="1300">
+                <a:solidFill>
+                  <a:srgbClr val="222222"/>
+                </a:solidFill>
+              </a:rPr>
+              <a:t>•  user_prior_attempts, user_prior_correct_rate — история студента.</a:t>
+            </a:r>
+          </a:p>
+          <a:p>
+            <a:pPr>
+              <a:spcAft>
+                <a:spcPts val="600"/>
+              </a:spcAft>
+            </a:pPr>
+            <a:r>
+              <a:rPr sz="1300">
+                <a:solidFill>
+                  <a:srgbClr val="222222"/>
+                </a:solidFill>
+              </a:rPr>
+              <a:t>•  skill_prior_attempts, skill_prior_correct_rate — история по навыку.</a:t>
+            </a:r>
+          </a:p>
+          <a:p>
+            <a:pPr>
+              <a:spcAft>
+                <a:spcPts val="600"/>
+              </a:spcAft>
+            </a:pPr>
+            <a:r>
+              <a:rPr sz="1300">
+                <a:solidFill>
+                  <a:srgbClr val="222222"/>
+                </a:solidFill>
+              </a:rPr>
+              <a:t>•  recent3_correct_rate — успешность за 3 последних шага.</a:t>
+            </a:r>
+          </a:p>
+          <a:p>
+            <a:pPr>
+              <a:spcAft>
+                <a:spcPts val="600"/>
+              </a:spcAft>
+            </a:pPr>
+            <a:r>
+              <a:rPr sz="1300">
+                <a:solidFill>
+                  <a:srgbClr val="222222"/>
+                </a:solidFill>
+              </a:rPr>
+              <a:t>•  skill_difficulty (вычислена только на train, чтобы избежать утечки).</a:t>
             </a:r>
           </a:p>
         </p:txBody>
       </p:sp>
       <p:pic>
         <p:nvPicPr>
-          <p:cNvPr id="4" name="Picture 3" descr="dataset_overview.png"/>
+          <p:cNvPr id="7" name="Picture 6" descr="dataset_overview.png"/>
           <p:cNvPicPr>
             <a:picLocks noChangeAspect="1"/>
           </p:cNvPicPr>
@@ -3422,8 +3850,8 @@
         </p:blipFill>
         <p:spPr>
           <a:xfrm>
-            <a:off x="6492240" y="1371600"/>
-            <a:ext cx="5303520" cy="2107684"/>
+            <a:off x="6675120" y="1371600"/>
+            <a:ext cx="5212080" cy="2071344"/>
           </a:xfrm>
           <a:prstGeom prst="rect">
             <a:avLst/>
@@ -3456,8 +3884,8 @@
         </p:nvSpPr>
         <p:spPr>
           <a:xfrm>
-            <a:off x="548640" y="365760"/>
-            <a:ext cx="10972800" cy="914400"/>
+            <a:off x="548640" y="320040"/>
+            <a:ext cx="11064240" cy="822960"/>
           </a:xfrm>
           <a:prstGeom prst="rect">
             <a:avLst/>
@@ -3471,12 +3899,12 @@
           <a:lstStyle/>
           <a:p>
             <a:r>
-              <a:rPr sz="3200" b="1">
+              <a:rPr sz="3000" b="1">
                 <a:solidFill>
                   <a:srgbClr val="1F2D5A"/>
                 </a:solidFill>
               </a:rPr>
-              <a:t>Архитектура ML-системы</a:t>
+              <a:t>Архитектура решения и три уровня автоматизации</a:t>
             </a:r>
           </a:p>
         </p:txBody>
@@ -3489,8 +3917,8 @@
         </p:nvSpPr>
         <p:spPr>
           <a:xfrm>
-            <a:off x="640080" y="1371600"/>
-            <a:ext cx="10972800" cy="5029200"/>
+            <a:off x="548640" y="1188720"/>
+            <a:ext cx="11064240" cy="457200"/>
           </a:xfrm>
           <a:prstGeom prst="rect">
             <a:avLst/>
@@ -3505,67 +3933,281 @@
           <a:p>
             <a:pPr>
               <a:spcAft>
-                <a:spcPts val="800"/>
-              </a:spcAft>
-            </a:pPr>
-            <a:r>
-              <a:rPr sz="1800"/>
-              <a:t>•  ETL: Extract (загрузка/кэш) → Transform (очистка, признаки, сплит) → Load (parquet).</a:t>
-            </a:r>
-          </a:p>
-          <a:p>
-            <a:pPr>
-              <a:spcAft>
-                <a:spcPts val="800"/>
-              </a:spcAft>
-            </a:pPr>
-            <a:r>
-              <a:rPr sz="1800"/>
-              <a:t>•  Модели: BKT (байесовский baseline), DKT (LSTM),</a:t>
-            </a:r>
-          </a:p>
-          <a:p>
-            <a:pPr>
-              <a:spcAft>
-                <a:spcPts val="800"/>
-              </a:spcAft>
-            </a:pPr>
-            <a:r>
-              <a:rPr sz="1800"/>
-              <a:t>•  DKT+Optuna (автопоиск архитектуры), AutoML FLAML (выбор модели+гиперпараметров).</a:t>
-            </a:r>
-          </a:p>
-          <a:p>
-            <a:pPr>
-              <a:spcAft>
-                <a:spcPts val="800"/>
-              </a:spcAft>
-            </a:pPr>
-            <a:r>
-              <a:rPr sz="1800"/>
-              <a:t>•  Контейнеризация: Docker (slim, non-root); оркестрация — единый pipeline.py.</a:t>
-            </a:r>
-          </a:p>
-          <a:p>
-            <a:pPr>
-              <a:spcAft>
-                <a:spcPts val="800"/>
-              </a:spcAft>
-            </a:pPr>
-            <a:r>
-              <a:rPr sz="1800"/>
-              <a:t>•  CI/CD: GitHub Actions (lint + pytest + docker build + smoke-run).</a:t>
-            </a:r>
-          </a:p>
-          <a:p>
-            <a:pPr>
-              <a:spcAft>
-                <a:spcPts val="800"/>
-              </a:spcAft>
-            </a:pPr>
-            <a:r>
-              <a:rPr sz="1800"/>
-              <a:t>•  Мониторинг: MLflow (метрики/артефакты), PSI-дрейф, контроль качества данных, ресурсы.</a:t>
+                <a:spcPts val="600"/>
+              </a:spcAft>
+            </a:pPr>
+            <a:r>
+              <a:rPr sz="1700" b="1">
+                <a:solidFill>
+                  <a:srgbClr val="1F2D5A"/>
+                </a:solidFill>
+              </a:rPr>
+              <a:t>Поток данных</a:t>
+            </a:r>
+          </a:p>
+        </p:txBody>
+      </p:sp>
+      <p:sp>
+        <p:nvSpPr>
+          <p:cNvPr id="4" name="TextBox 3"/>
+          <p:cNvSpPr txBox="1"/>
+          <p:nvPr/>
+        </p:nvSpPr>
+        <p:spPr>
+          <a:xfrm>
+            <a:off x="548640" y="1645920"/>
+            <a:ext cx="11064240" cy="457200"/>
+          </a:xfrm>
+          <a:prstGeom prst="rect">
+            <a:avLst/>
+          </a:prstGeom>
+          <a:noFill/>
+        </p:spPr>
+        <p:txBody>
+          <a:bodyPr wrap="square">
+            <a:spAutoFit/>
+          </a:bodyPr>
+          <a:lstStyle/>
+          <a:p>
+            <a:pPr>
+              <a:spcAft>
+                <a:spcPts val="600"/>
+              </a:spcAft>
+            </a:pPr>
+            <a:r>
+              <a:rPr sz="1300" b="0">
+                <a:solidFill>
+                  <a:srgbClr val="222222"/>
+                </a:solidFill>
+              </a:rPr>
+              <a:t>Extract → Transform → Load → Data-quality gate → 4 модели → Оценка → Визуализация → MLflow</a:t>
+            </a:r>
+          </a:p>
+        </p:txBody>
+      </p:sp>
+      <p:sp>
+        <p:nvSpPr>
+          <p:cNvPr id="5" name="TextBox 4"/>
+          <p:cNvSpPr txBox="1"/>
+          <p:nvPr/>
+        </p:nvSpPr>
+        <p:spPr>
+          <a:xfrm>
+            <a:off x="548640" y="2377440"/>
+            <a:ext cx="11064240" cy="457200"/>
+          </a:xfrm>
+          <a:prstGeom prst="rect">
+            <a:avLst/>
+          </a:prstGeom>
+          <a:noFill/>
+        </p:spPr>
+        <p:txBody>
+          <a:bodyPr wrap="square">
+            <a:spAutoFit/>
+          </a:bodyPr>
+          <a:lstStyle/>
+          <a:p>
+            <a:pPr>
+              <a:spcAft>
+                <a:spcPts val="600"/>
+              </a:spcAft>
+            </a:pPr>
+            <a:r>
+              <a:rPr sz="1700" b="1">
+                <a:solidFill>
+                  <a:srgbClr val="1F2D5A"/>
+                </a:solidFill>
+              </a:rPr>
+              <a:t>Четыре модели разной природы</a:t>
+            </a:r>
+          </a:p>
+        </p:txBody>
+      </p:sp>
+      <p:sp>
+        <p:nvSpPr>
+          <p:cNvPr id="6" name="TextBox 5"/>
+          <p:cNvSpPr txBox="1"/>
+          <p:nvPr/>
+        </p:nvSpPr>
+        <p:spPr>
+          <a:xfrm>
+            <a:off x="548640" y="2834640"/>
+            <a:ext cx="11064240" cy="1645920"/>
+          </a:xfrm>
+          <a:prstGeom prst="rect">
+            <a:avLst/>
+          </a:prstGeom>
+          <a:noFill/>
+        </p:spPr>
+        <p:txBody>
+          <a:bodyPr wrap="square">
+            <a:spAutoFit/>
+          </a:bodyPr>
+          <a:lstStyle/>
+          <a:p>
+            <a:pPr>
+              <a:spcAft>
+                <a:spcPts val="600"/>
+              </a:spcAft>
+            </a:pPr>
+            <a:r>
+              <a:rPr sz="1400">
+                <a:solidFill>
+                  <a:srgbClr val="222222"/>
+                </a:solidFill>
+              </a:rPr>
+              <a:t>•  BKT — скрытая марковская модель (EM-обучение, один набор параметров на навык). Интерпретируемый baseline.</a:t>
+            </a:r>
+          </a:p>
+          <a:p>
+            <a:pPr>
+              <a:spcAft>
+                <a:spcPts val="600"/>
+              </a:spcAft>
+            </a:pPr>
+            <a:r>
+              <a:rPr sz="1400">
+                <a:solidFill>
+                  <a:srgbClr val="222222"/>
+                </a:solidFill>
+              </a:rPr>
+              <a:t>•  DKT — рекуррентная нейросеть (Embedding → LSTM → Linear). Моделирует длинные зависимости.</a:t>
+            </a:r>
+          </a:p>
+          <a:p>
+            <a:pPr>
+              <a:spcAft>
+                <a:spcPts val="600"/>
+              </a:spcAft>
+            </a:pPr>
+            <a:r>
+              <a:rPr sz="1400">
+                <a:solidFill>
+                  <a:srgbClr val="222222"/>
+                </a:solidFill>
+              </a:rPr>
+              <a:t>•  DKT + Optuna — TPE-поиск архитектуры (embed_dim, hidden_dim, dropout, lr, batch_size).</a:t>
+            </a:r>
+          </a:p>
+          <a:p>
+            <a:pPr>
+              <a:spcAft>
+                <a:spcPts val="600"/>
+              </a:spcAft>
+            </a:pPr>
+            <a:r>
+              <a:rPr sz="1400">
+                <a:solidFill>
+                  <a:srgbClr val="222222"/>
+                </a:solidFill>
+              </a:rPr>
+              <a:t>•  AutoML (FLAML) — выбор модели и гиперпараметров за фиксированный бюджет времени.</a:t>
+            </a:r>
+          </a:p>
+        </p:txBody>
+      </p:sp>
+      <p:sp>
+        <p:nvSpPr>
+          <p:cNvPr id="7" name="TextBox 6"/>
+          <p:cNvSpPr txBox="1"/>
+          <p:nvPr/>
+        </p:nvSpPr>
+        <p:spPr>
+          <a:xfrm>
+            <a:off x="548640" y="4663440"/>
+            <a:ext cx="11064240" cy="457200"/>
+          </a:xfrm>
+          <a:prstGeom prst="rect">
+            <a:avLst/>
+          </a:prstGeom>
+          <a:noFill/>
+        </p:spPr>
+        <p:txBody>
+          <a:bodyPr wrap="square">
+            <a:spAutoFit/>
+          </a:bodyPr>
+          <a:lstStyle/>
+          <a:p>
+            <a:pPr>
+              <a:spcAft>
+                <a:spcPts val="600"/>
+              </a:spcAft>
+            </a:pPr>
+            <a:r>
+              <a:rPr sz="1700" b="1">
+                <a:solidFill>
+                  <a:srgbClr val="1F2D5A"/>
+                </a:solidFill>
+              </a:rPr>
+              <a:t>Три уровня автоматизации</a:t>
+            </a:r>
+          </a:p>
+        </p:txBody>
+      </p:sp>
+      <p:sp>
+        <p:nvSpPr>
+          <p:cNvPr id="8" name="TextBox 7"/>
+          <p:cNvSpPr txBox="1"/>
+          <p:nvPr/>
+        </p:nvSpPr>
+        <p:spPr>
+          <a:xfrm>
+            <a:off x="548640" y="5120640"/>
+            <a:ext cx="11064240" cy="1463040"/>
+          </a:xfrm>
+          <a:prstGeom prst="rect">
+            <a:avLst/>
+          </a:prstGeom>
+          <a:noFill/>
+        </p:spPr>
+        <p:txBody>
+          <a:bodyPr wrap="square">
+            <a:spAutoFit/>
+          </a:bodyPr>
+          <a:lstStyle/>
+          <a:p>
+            <a:pPr>
+              <a:spcAft>
+                <a:spcPts val="600"/>
+              </a:spcAft>
+            </a:pPr>
+            <a:r>
+              <a:rPr sz="1400">
+                <a:solidFill>
+                  <a:srgbClr val="222222"/>
+                </a:solidFill>
+              </a:rPr>
+              <a:t>•  1. Выбор модели и гиперпараметров — FLAML на табличных признаках.</a:t>
+            </a:r>
+          </a:p>
+          <a:p>
+            <a:pPr>
+              <a:spcAft>
+                <a:spcPts val="600"/>
+              </a:spcAft>
+            </a:pPr>
+            <a:r>
+              <a:rPr sz="1400">
+                <a:solidFill>
+                  <a:srgbClr val="222222"/>
+                </a:solidFill>
+              </a:rPr>
+              <a:t>•  2. Поиск архитектуры нейросети — Optuna поверх DKT (25 trials).</a:t>
+            </a:r>
+          </a:p>
+          <a:p>
+            <a:pPr>
+              <a:spcAft>
+                <a:spcPts val="600"/>
+              </a:spcAft>
+            </a:pPr>
+            <a:r>
+              <a:rPr sz="1400">
+                <a:solidFill>
+                  <a:srgbClr val="222222"/>
+                </a:solidFill>
+              </a:rPr>
+              <a:t>•  3. Сквозная оркестрация — один запуск pipeline.py выполняет весь цикл.</a:t>
             </a:r>
           </a:p>
         </p:txBody>
@@ -3596,8 +4238,8 @@
         </p:nvSpPr>
         <p:spPr>
           <a:xfrm>
-            <a:off x="548640" y="365760"/>
-            <a:ext cx="10972800" cy="914400"/>
+            <a:off x="548640" y="320040"/>
+            <a:ext cx="11064240" cy="822960"/>
           </a:xfrm>
           <a:prstGeom prst="rect">
             <a:avLst/>
@@ -3611,12 +4253,12 @@
           <a:lstStyle/>
           <a:p>
             <a:r>
-              <a:rPr sz="3200" b="1">
+              <a:rPr sz="3000" b="1">
                 <a:solidFill>
                   <a:srgbClr val="1F2D5A"/>
                 </a:solidFill>
               </a:rPr>
-              <a:t>Результаты тестирования модели</a:t>
+              <a:t>Результаты на отложенной тестовой выборке</a:t>
             </a:r>
           </a:p>
         </p:txBody>
@@ -3630,8 +4272,8 @@
           <p:nvPr/>
         </p:nvGraphicFramePr>
         <p:xfrm>
-          <a:off x="640080" y="1463040"/>
-          <a:ext cx="5486400" cy="1828800"/>
+          <a:off x="548640" y="1280160"/>
+          <a:ext cx="5943600" cy="1828800"/>
         </p:xfrm>
         <a:graphic>
           <a:graphicData uri="http://schemas.openxmlformats.org/drawingml/2006/table">
@@ -3640,11 +4282,11 @@
                 <a:tableStyleId>{5C22544A-7EE6-4342-B048-85BDC9FD1C3A}</a:tableStyleId>
               </a:tblPr>
               <a:tblGrid>
-                <a:gridCol w="1097280"/>
-                <a:gridCol w="1097280"/>
-                <a:gridCol w="1097280"/>
-                <a:gridCol w="1097280"/>
-                <a:gridCol w="1097280"/>
+                <a:gridCol w="1188720"/>
+                <a:gridCol w="1188720"/>
+                <a:gridCol w="1188720"/>
+                <a:gridCol w="1188720"/>
+                <a:gridCol w="1188720"/>
               </a:tblGrid>
               <a:tr h="365760">
                 <a:tc>
@@ -3653,7 +4295,11 @@
                     <a:lstStyle/>
                     <a:p>
                       <a:r>
-                        <a:rPr b="1" sz="1300"/>
+                        <a:rPr b="1" sz="1300">
+                          <a:solidFill>
+                            <a:srgbClr val="1F2D5A"/>
+                          </a:solidFill>
+                        </a:rPr>
                         <a:t>Модель</a:t>
                       </a:r>
                     </a:p>
@@ -3666,7 +4312,11 @@
                     <a:lstStyle/>
                     <a:p>
                       <a:r>
-                        <a:rPr b="1" sz="1300"/>
+                        <a:rPr b="1" sz="1300">
+                          <a:solidFill>
+                            <a:srgbClr val="1F2D5A"/>
+                          </a:solidFill>
+                        </a:rPr>
                         <a:t>AUC</a:t>
                       </a:r>
                     </a:p>
@@ -3679,7 +4329,11 @@
                     <a:lstStyle/>
                     <a:p>
                       <a:r>
-                        <a:rPr b="1" sz="1300"/>
+                        <a:rPr b="1" sz="1300">
+                          <a:solidFill>
+                            <a:srgbClr val="1F2D5A"/>
+                          </a:solidFill>
+                        </a:rPr>
                         <a:t>Accuracy</a:t>
                       </a:r>
                     </a:p>
@@ -3692,7 +4346,11 @@
                     <a:lstStyle/>
                     <a:p>
                       <a:r>
-                        <a:rPr b="1" sz="1300"/>
+                        <a:rPr b="1" sz="1300">
+                          <a:solidFill>
+                            <a:srgbClr val="1F2D5A"/>
+                          </a:solidFill>
+                        </a:rPr>
                         <a:t>F1</a:t>
                       </a:r>
                     </a:p>
@@ -3705,7 +4363,11 @@
                     <a:lstStyle/>
                     <a:p>
                       <a:r>
-                        <a:rPr b="1" sz="1300"/>
+                        <a:rPr b="1" sz="1300">
+                          <a:solidFill>
+                            <a:srgbClr val="1F2D5A"/>
+                          </a:solidFill>
+                        </a:rPr>
                         <a:t>RMSE</a:t>
                       </a:r>
                     </a:p>
@@ -3720,7 +4382,11 @@
                     <a:lstStyle/>
                     <a:p>
                       <a:r>
-                        <a:rPr sz="1200"/>
+                        <a:rPr sz="1200" b="0">
+                          <a:solidFill>
+                            <a:srgbClr val="222222"/>
+                          </a:solidFill>
+                        </a:rPr>
                         <a:t>BKT</a:t>
                       </a:r>
                     </a:p>
@@ -3733,8 +4399,12 @@
                     <a:lstStyle/>
                     <a:p>
                       <a:r>
-                        <a:rPr sz="1200"/>
-                        <a:t>0.720</a:t>
+                        <a:rPr sz="1200" b="0">
+                          <a:solidFill>
+                            <a:srgbClr val="222222"/>
+                          </a:solidFill>
+                        </a:rPr>
+                        <a:t>0.7200</a:t>
                       </a:r>
                     </a:p>
                   </a:txBody>
@@ -3746,8 +4416,12 @@
                     <a:lstStyle/>
                     <a:p>
                       <a:r>
-                        <a:rPr sz="1200"/>
-                        <a:t>0.705</a:t>
+                        <a:rPr sz="1200" b="0">
+                          <a:solidFill>
+                            <a:srgbClr val="222222"/>
+                          </a:solidFill>
+                        </a:rPr>
+                        <a:t>0.7046</a:t>
                       </a:r>
                     </a:p>
                   </a:txBody>
@@ -3759,8 +4433,12 @@
                     <a:lstStyle/>
                     <a:p>
                       <a:r>
-                        <a:rPr sz="1200"/>
-                        <a:t>0.789</a:t>
+                        <a:rPr sz="1200" b="0">
+                          <a:solidFill>
+                            <a:srgbClr val="222222"/>
+                          </a:solidFill>
+                        </a:rPr>
+                        <a:t>0.7888</a:t>
                       </a:r>
                     </a:p>
                   </a:txBody>
@@ -3772,8 +4450,12 @@
                     <a:lstStyle/>
                     <a:p>
                       <a:r>
-                        <a:rPr sz="1200"/>
-                        <a:t>0.444</a:t>
+                        <a:rPr sz="1200" b="0">
+                          <a:solidFill>
+                            <a:srgbClr val="222222"/>
+                          </a:solidFill>
+                        </a:rPr>
+                        <a:t>0.4440</a:t>
                       </a:r>
                     </a:p>
                   </a:txBody>
@@ -3787,7 +4469,11 @@
                     <a:lstStyle/>
                     <a:p>
                       <a:r>
-                        <a:rPr sz="1200"/>
+                        <a:rPr sz="1200" b="0">
+                          <a:solidFill>
+                            <a:srgbClr val="222222"/>
+                          </a:solidFill>
+                        </a:rPr>
                         <a:t>DKT</a:t>
                       </a:r>
                     </a:p>
@@ -3800,8 +4486,12 @@
                     <a:lstStyle/>
                     <a:p>
                       <a:r>
-                        <a:rPr sz="1200"/>
-                        <a:t>0.811</a:t>
+                        <a:rPr sz="1200" b="0">
+                          <a:solidFill>
+                            <a:srgbClr val="222222"/>
+                          </a:solidFill>
+                        </a:rPr>
+                        <a:t>0.8015</a:t>
                       </a:r>
                     </a:p>
                   </a:txBody>
@@ -3813,8 +4503,12 @@
                     <a:lstStyle/>
                     <a:p>
                       <a:r>
-                        <a:rPr sz="1200"/>
-                        <a:t>0.756</a:t>
+                        <a:rPr sz="1200" b="0">
+                          <a:solidFill>
+                            <a:srgbClr val="222222"/>
+                          </a:solidFill>
+                        </a:rPr>
+                        <a:t>0.7504</a:t>
                       </a:r>
                     </a:p>
                   </a:txBody>
@@ -3826,8 +4520,12 @@
                     <a:lstStyle/>
                     <a:p>
                       <a:r>
-                        <a:rPr sz="1200"/>
-                        <a:t>0.823</a:t>
+                        <a:rPr sz="1200" b="0">
+                          <a:solidFill>
+                            <a:srgbClr val="222222"/>
+                          </a:solidFill>
+                        </a:rPr>
+                        <a:t>0.8175</a:t>
                       </a:r>
                     </a:p>
                   </a:txBody>
@@ -3839,8 +4537,12 @@
                     <a:lstStyle/>
                     <a:p>
                       <a:r>
-                        <a:rPr sz="1200"/>
-                        <a:t>0.405</a:t>
+                        <a:rPr sz="1200" b="0">
+                          <a:solidFill>
+                            <a:srgbClr val="222222"/>
+                          </a:solidFill>
+                        </a:rPr>
+                        <a:t>0.4129</a:t>
                       </a:r>
                     </a:p>
                   </a:txBody>
@@ -3854,7 +4556,11 @@
                     <a:lstStyle/>
                     <a:p>
                       <a:r>
-                        <a:rPr sz="1200"/>
+                        <a:rPr sz="1200" b="1">
+                          <a:solidFill>
+                            <a:srgbClr val="1F2D5A"/>
+                          </a:solidFill>
+                        </a:rPr>
                         <a:t>DKT+Optuna</a:t>
                       </a:r>
                     </a:p>
@@ -3867,8 +4573,12 @@
                     <a:lstStyle/>
                     <a:p>
                       <a:r>
-                        <a:rPr sz="1200"/>
-                        <a:t>0.816</a:t>
+                        <a:rPr sz="1200" b="1">
+                          <a:solidFill>
+                            <a:srgbClr val="1F2D5A"/>
+                          </a:solidFill>
+                        </a:rPr>
+                        <a:t>0.8036</a:t>
                       </a:r>
                     </a:p>
                   </a:txBody>
@@ -3880,8 +4590,12 @@
                     <a:lstStyle/>
                     <a:p>
                       <a:r>
-                        <a:rPr sz="1200"/>
-                        <a:t>0.761</a:t>
+                        <a:rPr sz="1200" b="1">
+                          <a:solidFill>
+                            <a:srgbClr val="1F2D5A"/>
+                          </a:solidFill>
+                        </a:rPr>
+                        <a:t>0.7511</a:t>
                       </a:r>
                     </a:p>
                   </a:txBody>
@@ -3893,8 +4607,12 @@
                     <a:lstStyle/>
                     <a:p>
                       <a:r>
-                        <a:rPr sz="1200"/>
-                        <a:t>0.826</a:t>
+                        <a:rPr sz="1200" b="1">
+                          <a:solidFill>
+                            <a:srgbClr val="1F2D5A"/>
+                          </a:solidFill>
+                        </a:rPr>
+                        <a:t>0.8197</a:t>
                       </a:r>
                     </a:p>
                   </a:txBody>
@@ -3906,8 +4624,12 @@
                     <a:lstStyle/>
                     <a:p>
                       <a:r>
-                        <a:rPr sz="1200"/>
-                        <a:t>0.402</a:t>
+                        <a:rPr sz="1200" b="1">
+                          <a:solidFill>
+                            <a:srgbClr val="1F2D5A"/>
+                          </a:solidFill>
+                        </a:rPr>
+                        <a:t>0.4116</a:t>
                       </a:r>
                     </a:p>
                   </a:txBody>
@@ -3921,7 +4643,11 @@
                     <a:lstStyle/>
                     <a:p>
                       <a:r>
-                        <a:rPr sz="1200"/>
+                        <a:rPr sz="1200" b="0">
+                          <a:solidFill>
+                            <a:srgbClr val="222222"/>
+                          </a:solidFill>
+                        </a:rPr>
                         <a:t>AutoML</a:t>
                       </a:r>
                     </a:p>
@@ -3934,8 +4660,12 @@
                     <a:lstStyle/>
                     <a:p>
                       <a:r>
-                        <a:rPr sz="1200"/>
-                        <a:t>0.788</a:t>
+                        <a:rPr sz="1200" b="0">
+                          <a:solidFill>
+                            <a:srgbClr val="222222"/>
+                          </a:solidFill>
+                        </a:rPr>
+                        <a:t>0.7914</a:t>
                       </a:r>
                     </a:p>
                   </a:txBody>
@@ -3947,8 +4677,12 @@
                     <a:lstStyle/>
                     <a:p>
                       <a:r>
-                        <a:rPr sz="1200"/>
-                        <a:t>0.743</a:t>
+                        <a:rPr sz="1200" b="0">
+                          <a:solidFill>
+                            <a:srgbClr val="222222"/>
+                          </a:solidFill>
+                        </a:rPr>
+                        <a:t>0.7455</a:t>
                       </a:r>
                     </a:p>
                   </a:txBody>
@@ -3960,8 +4694,12 @@
                     <a:lstStyle/>
                     <a:p>
                       <a:r>
-                        <a:rPr sz="1200"/>
-                        <a:t>0.815</a:t>
+                        <a:rPr sz="1200" b="0">
+                          <a:solidFill>
+                            <a:srgbClr val="222222"/>
+                          </a:solidFill>
+                        </a:rPr>
+                        <a:t>0.8173</a:t>
                       </a:r>
                     </a:p>
                   </a:txBody>
@@ -3973,8 +4711,12 @@
                     <a:lstStyle/>
                     <a:p>
                       <a:r>
-                        <a:rPr sz="1200"/>
-                        <a:t>0.416</a:t>
+                        <a:rPr sz="1200" b="0">
+                          <a:solidFill>
+                            <a:srgbClr val="222222"/>
+                          </a:solidFill>
+                        </a:rPr>
+                        <a:t>0.4149</a:t>
                       </a:r>
                     </a:p>
                   </a:txBody>
@@ -4001,8 +4743,8 @@
         </p:blipFill>
         <p:spPr>
           <a:xfrm>
-            <a:off x="6400800" y="1463040"/>
-            <a:ext cx="5486400" cy="2995972"/>
+            <a:off x="6675120" y="1280160"/>
+            <a:ext cx="5212080" cy="2846174"/>
           </a:xfrm>
           <a:prstGeom prst="rect">
             <a:avLst/>
@@ -4017,8 +4759,8 @@
         </p:nvSpPr>
         <p:spPr>
           <a:xfrm>
-            <a:off x="640080" y="3383280"/>
-            <a:ext cx="5486400" cy="1097280"/>
+            <a:off x="548640" y="4572000"/>
+            <a:ext cx="11064240" cy="457200"/>
           </a:xfrm>
           <a:prstGeom prst="rect">
             <a:avLst/>
@@ -4026,18 +4768,91 @@
           <a:noFill/>
         </p:spPr>
         <p:txBody>
-          <a:bodyPr wrap="none">
+          <a:bodyPr wrap="square">
             <a:spAutoFit/>
           </a:bodyPr>
           <a:lstStyle/>
           <a:p>
-            <a:r>
-              <a:rPr sz="1400" b="1">
-                <a:solidFill>
-                  <a:srgbClr val="4C72B0"/>
-                </a:solidFill>
-              </a:rPr>
-              <a:t>Лучшая модель: DKT+Optuna · AutoML выбрал: xgboost</a:t>
+            <a:pPr>
+              <a:spcAft>
+                <a:spcPts val="600"/>
+              </a:spcAft>
+            </a:pPr>
+            <a:r>
+              <a:rPr sz="1600" b="1">
+                <a:solidFill>
+                  <a:srgbClr val="1F2D5A"/>
+                </a:solidFill>
+              </a:rPr>
+              <a:t>Интерпретация</a:t>
+            </a:r>
+          </a:p>
+        </p:txBody>
+      </p:sp>
+      <p:sp>
+        <p:nvSpPr>
+          <p:cNvPr id="6" name="TextBox 5"/>
+          <p:cNvSpPr txBox="1"/>
+          <p:nvPr/>
+        </p:nvSpPr>
+        <p:spPr>
+          <a:xfrm>
+            <a:off x="548640" y="4983480"/>
+            <a:ext cx="11064240" cy="1645920"/>
+          </a:xfrm>
+          <a:prstGeom prst="rect">
+            <a:avLst/>
+          </a:prstGeom>
+          <a:noFill/>
+        </p:spPr>
+        <p:txBody>
+          <a:bodyPr wrap="square">
+            <a:spAutoFit/>
+          </a:bodyPr>
+          <a:lstStyle/>
+          <a:p>
+            <a:pPr>
+              <a:spcAft>
+                <a:spcPts val="600"/>
+              </a:spcAft>
+            </a:pPr>
+            <a:r>
+              <a:rPr sz="1300">
+                <a:solidFill>
+                  <a:srgbClr val="222222"/>
+                </a:solidFill>
+              </a:rPr>
+              <a:t>•  Лучший результат — DKT+Optuna (AUC 0.8036); соответствует уровню публикуемых бенчмарков для DKT на ASSISTments 2009.</a:t>
+            </a:r>
+          </a:p>
+          <a:p>
+            <a:pPr>
+              <a:spcAft>
+                <a:spcPts val="600"/>
+              </a:spcAft>
+            </a:pPr>
+            <a:r>
+              <a:rPr sz="1300">
+                <a:solidFill>
+                  <a:srgbClr val="222222"/>
+                </a:solidFill>
+              </a:rPr>
+              <a:t>•  AutoML выбрал xgboost; уступает DKT на 0.010 AUC при полностью автоматической настройке.</a:t>
+            </a:r>
+          </a:p>
+          <a:p>
+            <a:pPr>
+              <a:spcAft>
+                <a:spcPts val="600"/>
+              </a:spcAft>
+            </a:pPr>
+            <a:r>
+              <a:rPr sz="1300">
+                <a:solidFill>
+                  <a:srgbClr val="222222"/>
+                </a:solidFill>
+              </a:rPr>
+              <a:t>•  Optuna нашёл конфигурацию с сильной регуляризацией (dropout 0.49), что указывает на склонность DKT к переобучению на данном объёме данных.</a:t>
             </a:r>
           </a:p>
         </p:txBody>
@@ -4068,8 +4883,8 @@
         </p:nvSpPr>
         <p:spPr>
           <a:xfrm>
-            <a:off x="548640" y="365760"/>
-            <a:ext cx="10972800" cy="914400"/>
+            <a:off x="548640" y="320040"/>
+            <a:ext cx="11064240" cy="822960"/>
           </a:xfrm>
           <a:prstGeom prst="rect">
             <a:avLst/>
@@ -4083,12 +4898,12 @@
           <a:lstStyle/>
           <a:p>
             <a:r>
-              <a:rPr sz="3200" b="1">
+              <a:rPr sz="3000" b="1">
                 <a:solidFill>
                   <a:srgbClr val="1F2D5A"/>
                 </a:solidFill>
               </a:rPr>
-              <a:t>Ключевые выводы для бизнеса</a:t>
+              <a:t>Мониторинг и воспроизводимость</a:t>
             </a:r>
           </a:p>
         </p:txBody>
@@ -4101,8 +4916,8 @@
         </p:nvSpPr>
         <p:spPr>
           <a:xfrm>
-            <a:off x="640080" y="1371600"/>
-            <a:ext cx="10972800" cy="5029200"/>
+            <a:off x="548640" y="1188720"/>
+            <a:ext cx="5852160" cy="457200"/>
           </a:xfrm>
           <a:prstGeom prst="rect">
             <a:avLst/>
@@ -4117,56 +4932,755 @@
           <a:p>
             <a:pPr>
               <a:spcAft>
-                <a:spcPts val="800"/>
-              </a:spcAft>
-            </a:pPr>
-            <a:r>
-              <a:rPr sz="1800"/>
-              <a:t>•  Лучшая модель — DKT+Optuna: AUC = 0.816 на отложенной выборке.</a:t>
-            </a:r>
-          </a:p>
-          <a:p>
-            <a:pPr>
-              <a:spcAft>
-                <a:spcPts val="800"/>
-              </a:spcAft>
-            </a:pPr>
-            <a:r>
-              <a:rPr sz="1800"/>
-              <a:t>•  Глубокие модели (DKT) превосходят классический BKT на реальных данных.</a:t>
-            </a:r>
-          </a:p>
-          <a:p>
-            <a:pPr>
-              <a:spcAft>
-                <a:spcPts val="800"/>
-              </a:spcAft>
-            </a:pPr>
-            <a:r>
-              <a:rPr sz="1800"/>
-              <a:t>•  AutoML/Optuna автоматизируют подбор модели → быстрее итерации, меньше ручного труда.</a:t>
-            </a:r>
-          </a:p>
-          <a:p>
-            <a:pPr>
-              <a:spcAft>
-                <a:spcPts val="800"/>
-              </a:spcAft>
-            </a:pPr>
-            <a:r>
-              <a:rPr sz="1800"/>
-              <a:t>•  Прогноз даёт основу для адаптивных рекомендаций и раннего выявления пробелов.</a:t>
-            </a:r>
-          </a:p>
-          <a:p>
-            <a:pPr>
-              <a:spcAft>
-                <a:spcPts val="800"/>
-              </a:spcAft>
-            </a:pPr>
-            <a:r>
-              <a:rPr sz="1800"/>
-              <a:t>•  Пайплайн воспроизводим (Docker+CI) и наблюдаем (MLflow+дрейф) — готов к развитию.</a:t>
+                <a:spcPts val="600"/>
+              </a:spcAft>
+            </a:pPr>
+            <a:r>
+              <a:rPr sz="1600" b="1">
+                <a:solidFill>
+                  <a:srgbClr val="1F2D5A"/>
+                </a:solidFill>
+              </a:rPr>
+              <a:t>Мониторинг качества данных</a:t>
+            </a:r>
+          </a:p>
+        </p:txBody>
+      </p:sp>
+      <p:sp>
+        <p:nvSpPr>
+          <p:cNvPr id="4" name="TextBox 3"/>
+          <p:cNvSpPr txBox="1"/>
+          <p:nvPr/>
+        </p:nvSpPr>
+        <p:spPr>
+          <a:xfrm>
+            <a:off x="548640" y="1645920"/>
+            <a:ext cx="5852160" cy="1645920"/>
+          </a:xfrm>
+          <a:prstGeom prst="rect">
+            <a:avLst/>
+          </a:prstGeom>
+          <a:noFill/>
+        </p:spPr>
+        <p:txBody>
+          <a:bodyPr wrap="square">
+            <a:spAutoFit/>
+          </a:bodyPr>
+          <a:lstStyle/>
+          <a:p>
+            <a:pPr>
+              <a:spcAft>
+                <a:spcPts val="600"/>
+              </a:spcAft>
+            </a:pPr>
+            <a:r>
+              <a:rPr sz="1300">
+                <a:solidFill>
+                  <a:srgbClr val="222222"/>
+                </a:solidFill>
+              </a:rPr>
+              <a:t>•  Data-quality gate: 5 проверок (схема, пропуски, бинарные метки, диапазоны, дубликаты).</a:t>
+            </a:r>
+          </a:p>
+          <a:p>
+            <a:pPr>
+              <a:spcAft>
+                <a:spcPts val="600"/>
+              </a:spcAft>
+            </a:pPr>
+            <a:r>
+              <a:rPr sz="1300">
+                <a:solidFill>
+                  <a:srgbClr val="222222"/>
+                </a:solidFill>
+              </a:rPr>
+              <a:t>•  Статус текущего прогона: passed = True.</a:t>
+            </a:r>
+          </a:p>
+          <a:p>
+            <a:pPr>
+              <a:spcAft>
+                <a:spcPts val="600"/>
+              </a:spcAft>
+            </a:pPr>
+            <a:r>
+              <a:rPr sz="1300">
+                <a:solidFill>
+                  <a:srgbClr val="222222"/>
+                </a:solidFill>
+              </a:rPr>
+              <a:t>•  Мониторинг дрейфа: PSI + KS-тест на 8 признаках.</a:t>
+            </a:r>
+          </a:p>
+          <a:p>
+            <a:pPr>
+              <a:spcAft>
+                <a:spcPts val="600"/>
+              </a:spcAft>
+            </a:pPr>
+            <a:r>
+              <a:rPr sz="1300">
+                <a:solidFill>
+                  <a:srgbClr val="222222"/>
+                </a:solidFill>
+              </a:rPr>
+              <a:t>•  Дрейфующих признаков: 0 (OK).</a:t>
+            </a:r>
+          </a:p>
+        </p:txBody>
+      </p:sp>
+      <p:sp>
+        <p:nvSpPr>
+          <p:cNvPr id="5" name="TextBox 4"/>
+          <p:cNvSpPr txBox="1"/>
+          <p:nvPr/>
+        </p:nvSpPr>
+        <p:spPr>
+          <a:xfrm>
+            <a:off x="548640" y="3474720"/>
+            <a:ext cx="5852160" cy="457200"/>
+          </a:xfrm>
+          <a:prstGeom prst="rect">
+            <a:avLst/>
+          </a:prstGeom>
+          <a:noFill/>
+        </p:spPr>
+        <p:txBody>
+          <a:bodyPr wrap="square">
+            <a:spAutoFit/>
+          </a:bodyPr>
+          <a:lstStyle/>
+          <a:p>
+            <a:pPr>
+              <a:spcAft>
+                <a:spcPts val="600"/>
+              </a:spcAft>
+            </a:pPr>
+            <a:r>
+              <a:rPr sz="1600" b="1">
+                <a:solidFill>
+                  <a:srgbClr val="1F2D5A"/>
+                </a:solidFill>
+              </a:rPr>
+              <a:t>Мониторинг ресурсов (psutil)</a:t>
+            </a:r>
+          </a:p>
+        </p:txBody>
+      </p:sp>
+      <p:sp>
+        <p:nvSpPr>
+          <p:cNvPr id="6" name="TextBox 5"/>
+          <p:cNvSpPr txBox="1"/>
+          <p:nvPr/>
+        </p:nvSpPr>
+        <p:spPr>
+          <a:xfrm>
+            <a:off x="548640" y="3931920"/>
+            <a:ext cx="5852160" cy="2103120"/>
+          </a:xfrm>
+          <a:prstGeom prst="rect">
+            <a:avLst/>
+          </a:prstGeom>
+          <a:noFill/>
+        </p:spPr>
+        <p:txBody>
+          <a:bodyPr wrap="square">
+            <a:spAutoFit/>
+          </a:bodyPr>
+          <a:lstStyle/>
+          <a:p>
+            <a:pPr>
+              <a:spcAft>
+                <a:spcPts val="600"/>
+              </a:spcAft>
+            </a:pPr>
+            <a:r>
+              <a:rPr sz="1300">
+                <a:solidFill>
+                  <a:srgbClr val="222222"/>
+                </a:solidFill>
+              </a:rPr>
+              <a:t>•  BKT: 14 с · 588 MB · 99% CPU.</a:t>
+            </a:r>
+          </a:p>
+          <a:p>
+            <a:pPr>
+              <a:spcAft>
+                <a:spcPts val="600"/>
+              </a:spcAft>
+            </a:pPr>
+            <a:r>
+              <a:rPr sz="1300">
+                <a:solidFill>
+                  <a:srgbClr val="222222"/>
+                </a:solidFill>
+              </a:rPr>
+              <a:t>•  DKT: 64 с · 626 MB · 99% CPU.</a:t>
+            </a:r>
+          </a:p>
+          <a:p>
+            <a:pPr>
+              <a:spcAft>
+                <a:spcPts val="600"/>
+              </a:spcAft>
+            </a:pPr>
+            <a:r>
+              <a:rPr sz="1300">
+                <a:solidFill>
+                  <a:srgbClr val="222222"/>
+                </a:solidFill>
+              </a:rPr>
+              <a:t>•  DKT + Optuna: 713 с · 298 MB · 100% CPU.</a:t>
+            </a:r>
+          </a:p>
+          <a:p>
+            <a:pPr>
+              <a:spcAft>
+                <a:spcPts val="600"/>
+              </a:spcAft>
+            </a:pPr>
+            <a:r>
+              <a:rPr sz="1300">
+                <a:solidFill>
+                  <a:srgbClr val="222222"/>
+                </a:solidFill>
+              </a:rPr>
+              <a:t>•  AutoML (FLAML): 618 с · 2389 MB · 396% CPU.</a:t>
+            </a:r>
+          </a:p>
+        </p:txBody>
+      </p:sp>
+      <p:sp>
+        <p:nvSpPr>
+          <p:cNvPr id="7" name="TextBox 6"/>
+          <p:cNvSpPr txBox="1"/>
+          <p:nvPr/>
+        </p:nvSpPr>
+        <p:spPr>
+          <a:xfrm>
+            <a:off x="6492240" y="1188720"/>
+            <a:ext cx="5394960" cy="457200"/>
+          </a:xfrm>
+          <a:prstGeom prst="rect">
+            <a:avLst/>
+          </a:prstGeom>
+          <a:noFill/>
+        </p:spPr>
+        <p:txBody>
+          <a:bodyPr wrap="square">
+            <a:spAutoFit/>
+          </a:bodyPr>
+          <a:lstStyle/>
+          <a:p>
+            <a:pPr>
+              <a:spcAft>
+                <a:spcPts val="600"/>
+              </a:spcAft>
+            </a:pPr>
+            <a:r>
+              <a:rPr sz="1600" b="1">
+                <a:solidFill>
+                  <a:srgbClr val="1F2D5A"/>
+                </a:solidFill>
+              </a:rPr>
+              <a:t>Воспроизводимость</a:t>
+            </a:r>
+          </a:p>
+        </p:txBody>
+      </p:sp>
+      <p:sp>
+        <p:nvSpPr>
+          <p:cNvPr id="8" name="TextBox 7"/>
+          <p:cNvSpPr txBox="1"/>
+          <p:nvPr/>
+        </p:nvSpPr>
+        <p:spPr>
+          <a:xfrm>
+            <a:off x="6492240" y="1645920"/>
+            <a:ext cx="5394960" cy="1828800"/>
+          </a:xfrm>
+          <a:prstGeom prst="rect">
+            <a:avLst/>
+          </a:prstGeom>
+          <a:noFill/>
+        </p:spPr>
+        <p:txBody>
+          <a:bodyPr wrap="square">
+            <a:spAutoFit/>
+          </a:bodyPr>
+          <a:lstStyle/>
+          <a:p>
+            <a:pPr>
+              <a:spcAft>
+                <a:spcPts val="600"/>
+              </a:spcAft>
+            </a:pPr>
+            <a:r>
+              <a:rPr sz="1300">
+                <a:solidFill>
+                  <a:srgbClr val="222222"/>
+                </a:solidFill>
+              </a:rPr>
+              <a:t>•  Docker: образ python:3.11-slim, non-root user, CPU-сборка torch.</a:t>
+            </a:r>
+          </a:p>
+          <a:p>
+            <a:pPr>
+              <a:spcAft>
+                <a:spcPts val="600"/>
+              </a:spcAft>
+            </a:pPr>
+            <a:r>
+              <a:rPr sz="1300">
+                <a:solidFill>
+                  <a:srgbClr val="222222"/>
+                </a:solidFill>
+              </a:rPr>
+              <a:t>•  docker-compose: сервисы pipeline + MLflow UI на одном томе.</a:t>
+            </a:r>
+          </a:p>
+          <a:p>
+            <a:pPr>
+              <a:spcAft>
+                <a:spcPts val="600"/>
+              </a:spcAft>
+            </a:pPr>
+            <a:r>
+              <a:rPr sz="1300">
+                <a:solidFill>
+                  <a:srgbClr val="222222"/>
+                </a:solidFill>
+              </a:rPr>
+              <a:t>•  CI/CD GitHub Actions: lint (ruff) + pytest + docker build + smoke-прогон.</a:t>
+            </a:r>
+          </a:p>
+          <a:p>
+            <a:pPr>
+              <a:spcAft>
+                <a:spcPts val="600"/>
+              </a:spcAft>
+            </a:pPr>
+            <a:r>
+              <a:rPr sz="1300">
+                <a:solidFill>
+                  <a:srgbClr val="222222"/>
+                </a:solidFill>
+              </a:rPr>
+              <a:t>•  MLflow: трекинг параметров, метрик, артефактов и обученных моделей.</a:t>
+            </a:r>
+          </a:p>
+        </p:txBody>
+      </p:sp>
+      <p:sp>
+        <p:nvSpPr>
+          <p:cNvPr id="9" name="TextBox 8"/>
+          <p:cNvSpPr txBox="1"/>
+          <p:nvPr/>
+        </p:nvSpPr>
+        <p:spPr>
+          <a:xfrm>
+            <a:off x="6492240" y="3657600"/>
+            <a:ext cx="5394960" cy="457200"/>
+          </a:xfrm>
+          <a:prstGeom prst="rect">
+            <a:avLst/>
+          </a:prstGeom>
+          <a:noFill/>
+        </p:spPr>
+        <p:txBody>
+          <a:bodyPr wrap="square">
+            <a:spAutoFit/>
+          </a:bodyPr>
+          <a:lstStyle/>
+          <a:p>
+            <a:pPr>
+              <a:spcAft>
+                <a:spcPts val="600"/>
+              </a:spcAft>
+            </a:pPr>
+            <a:r>
+              <a:rPr sz="1600" b="1">
+                <a:solidFill>
+                  <a:srgbClr val="1F2D5A"/>
+                </a:solidFill>
+              </a:rPr>
+              <a:t>Тестирование</a:t>
+            </a:r>
+          </a:p>
+        </p:txBody>
+      </p:sp>
+      <p:sp>
+        <p:nvSpPr>
+          <p:cNvPr id="10" name="TextBox 9"/>
+          <p:cNvSpPr txBox="1"/>
+          <p:nvPr/>
+        </p:nvSpPr>
+        <p:spPr>
+          <a:xfrm>
+            <a:off x="6492240" y="4114800"/>
+            <a:ext cx="5394960" cy="1828800"/>
+          </a:xfrm>
+          <a:prstGeom prst="rect">
+            <a:avLst/>
+          </a:prstGeom>
+          <a:noFill/>
+        </p:spPr>
+        <p:txBody>
+          <a:bodyPr wrap="square">
+            <a:spAutoFit/>
+          </a:bodyPr>
+          <a:lstStyle/>
+          <a:p>
+            <a:pPr>
+              <a:spcAft>
+                <a:spcPts val="600"/>
+              </a:spcAft>
+            </a:pPr>
+            <a:r>
+              <a:rPr sz="1300">
+                <a:solidFill>
+                  <a:srgbClr val="222222"/>
+                </a:solidFill>
+              </a:rPr>
+              <a:t>•  7 файлов на pytest, маркер slow для тяжёлых тестов.</a:t>
+            </a:r>
+          </a:p>
+          <a:p>
+            <a:pPr>
+              <a:spcAft>
+                <a:spcPts val="600"/>
+              </a:spcAft>
+            </a:pPr>
+            <a:r>
+              <a:rPr sz="1300">
+                <a:solidFill>
+                  <a:srgbClr val="222222"/>
+                </a:solidFill>
+              </a:rPr>
+              <a:t>•  Покрытие: ETL, Transform, метрики, BKT, мониторинг, smoke DKT/FLAML.</a:t>
+            </a:r>
+          </a:p>
+          <a:p>
+            <a:pPr>
+              <a:spcAft>
+                <a:spcPts val="600"/>
+              </a:spcAft>
+            </a:pPr>
+            <a:r>
+              <a:rPr sz="1300">
+                <a:solidFill>
+                  <a:srgbClr val="222222"/>
+                </a:solidFill>
+              </a:rPr>
+              <a:t>•  Линтер ruff (правила E, F, I, W).</a:t>
+            </a:r>
+          </a:p>
+        </p:txBody>
+      </p:sp>
+    </p:spTree>
+  </p:cSld>
+  <p:clrMapOvr>
+    <a:masterClrMapping/>
+  </p:clrMapOvr>
+</p:sld>
+</file>
+
+<file path=ppt/slides/slide7.xml><?xml version="1.0" encoding="utf-8"?>
+<p:sld xmlns:a="http://schemas.openxmlformats.org/drawingml/2006/main" xmlns:p="http://schemas.openxmlformats.org/presentationml/2006/main" xmlns:r="http://schemas.openxmlformats.org/officeDocument/2006/relationships">
+  <p:cSld>
+    <p:spTree>
+      <p:nvGrpSpPr>
+        <p:cNvPr id="1" name=""/>
+        <p:cNvGrpSpPr/>
+        <p:nvPr/>
+      </p:nvGrpSpPr>
+      <p:grpSpPr/>
+      <p:sp>
+        <p:nvSpPr>
+          <p:cNvPr id="2" name="TextBox 1"/>
+          <p:cNvSpPr txBox="1"/>
+          <p:nvPr/>
+        </p:nvSpPr>
+        <p:spPr>
+          <a:xfrm>
+            <a:off x="548640" y="320040"/>
+            <a:ext cx="11064240" cy="822960"/>
+          </a:xfrm>
+          <a:prstGeom prst="rect">
+            <a:avLst/>
+          </a:prstGeom>
+          <a:noFill/>
+        </p:spPr>
+        <p:txBody>
+          <a:bodyPr wrap="none">
+            <a:spAutoFit/>
+          </a:bodyPr>
+          <a:lstStyle/>
+          <a:p>
+            <a:r>
+              <a:rPr sz="3000" b="1">
+                <a:solidFill>
+                  <a:srgbClr val="1F2D5A"/>
+                </a:solidFill>
+              </a:rPr>
+              <a:t>Выводы</a:t>
+            </a:r>
+          </a:p>
+        </p:txBody>
+      </p:sp>
+      <p:sp>
+        <p:nvSpPr>
+          <p:cNvPr id="3" name="TextBox 2"/>
+          <p:cNvSpPr txBox="1"/>
+          <p:nvPr/>
+        </p:nvSpPr>
+        <p:spPr>
+          <a:xfrm>
+            <a:off x="548640" y="1188720"/>
+            <a:ext cx="11064240" cy="457200"/>
+          </a:xfrm>
+          <a:prstGeom prst="rect">
+            <a:avLst/>
+          </a:prstGeom>
+          <a:noFill/>
+        </p:spPr>
+        <p:txBody>
+          <a:bodyPr wrap="square">
+            <a:spAutoFit/>
+          </a:bodyPr>
+          <a:lstStyle/>
+          <a:p>
+            <a:pPr>
+              <a:spcAft>
+                <a:spcPts val="600"/>
+              </a:spcAft>
+            </a:pPr>
+            <a:r>
+              <a:rPr sz="1700" b="1">
+                <a:solidFill>
+                  <a:srgbClr val="1F2D5A"/>
+                </a:solidFill>
+              </a:rPr>
+              <a:t>Технические итоги</a:t>
+            </a:r>
+          </a:p>
+        </p:txBody>
+      </p:sp>
+      <p:sp>
+        <p:nvSpPr>
+          <p:cNvPr id="4" name="TextBox 3"/>
+          <p:cNvSpPr txBox="1"/>
+          <p:nvPr/>
+        </p:nvSpPr>
+        <p:spPr>
+          <a:xfrm>
+            <a:off x="548640" y="1645920"/>
+            <a:ext cx="11064240" cy="2011680"/>
+          </a:xfrm>
+          <a:prstGeom prst="rect">
+            <a:avLst/>
+          </a:prstGeom>
+          <a:noFill/>
+        </p:spPr>
+        <p:txBody>
+          <a:bodyPr wrap="square">
+            <a:spAutoFit/>
+          </a:bodyPr>
+          <a:lstStyle/>
+          <a:p>
+            <a:pPr>
+              <a:spcAft>
+                <a:spcPts val="600"/>
+              </a:spcAft>
+            </a:pPr>
+            <a:r>
+              <a:rPr sz="1400">
+                <a:solidFill>
+                  <a:srgbClr val="222222"/>
+                </a:solidFill>
+              </a:rPr>
+              <a:t>•  Реализован сквозной автоматизированный ML-пайплайн: ETL, четыре модели, оценка, мониторинг, упаковка.</a:t>
+            </a:r>
+          </a:p>
+          <a:p>
+            <a:pPr>
+              <a:spcAft>
+                <a:spcPts val="600"/>
+              </a:spcAft>
+            </a:pPr>
+            <a:r>
+              <a:rPr sz="1400">
+                <a:solidFill>
+                  <a:srgbClr val="222222"/>
+                </a:solidFill>
+              </a:rPr>
+              <a:t>•  Лучший результат — DKT+Optuna с AUC = 0.8036 на отложенной тестовой выборке.</a:t>
+            </a:r>
+          </a:p>
+          <a:p>
+            <a:pPr>
+              <a:spcAft>
+                <a:spcPts val="600"/>
+              </a:spcAft>
+            </a:pPr>
+            <a:r>
+              <a:rPr sz="1400">
+                <a:solidFill>
+                  <a:srgbClr val="222222"/>
+                </a:solidFill>
+              </a:rPr>
+              <a:t>•  Автоматизация на трёх уровнях: FLAML (модель + гиперпараметры), Optuna (архитектура DKT), pipeline.py (оркестрация).</a:t>
+            </a:r>
+          </a:p>
+          <a:p>
+            <a:pPr>
+              <a:spcAft>
+                <a:spcPts val="600"/>
+              </a:spcAft>
+            </a:pPr>
+            <a:r>
+              <a:rPr sz="1400">
+                <a:solidFill>
+                  <a:srgbClr val="222222"/>
+                </a:solidFill>
+              </a:rPr>
+              <a:t>•  Мониторинг качества данных, дрейфа (PSI + KS), ресурсов; всё логируется в MLflow.</a:t>
+            </a:r>
+          </a:p>
+          <a:p>
+            <a:pPr>
+              <a:spcAft>
+                <a:spcPts val="600"/>
+              </a:spcAft>
+            </a:pPr>
+            <a:r>
+              <a:rPr sz="1400">
+                <a:solidFill>
+                  <a:srgbClr val="222222"/>
+                </a:solidFill>
+              </a:rPr>
+              <a:t>•  Воспроизводимость обеспечена контейнером Docker и CI на GitHub Actions.</a:t>
+            </a:r>
+          </a:p>
+        </p:txBody>
+      </p:sp>
+      <p:sp>
+        <p:nvSpPr>
+          <p:cNvPr id="5" name="TextBox 4"/>
+          <p:cNvSpPr txBox="1"/>
+          <p:nvPr/>
+        </p:nvSpPr>
+        <p:spPr>
+          <a:xfrm>
+            <a:off x="548640" y="4023360"/>
+            <a:ext cx="11064240" cy="457200"/>
+          </a:xfrm>
+          <a:prstGeom prst="rect">
+            <a:avLst/>
+          </a:prstGeom>
+          <a:noFill/>
+        </p:spPr>
+        <p:txBody>
+          <a:bodyPr wrap="square">
+            <a:spAutoFit/>
+          </a:bodyPr>
+          <a:lstStyle/>
+          <a:p>
+            <a:pPr>
+              <a:spcAft>
+                <a:spcPts val="600"/>
+              </a:spcAft>
+            </a:pPr>
+            <a:r>
+              <a:rPr sz="1700" b="1">
+                <a:solidFill>
+                  <a:srgbClr val="1F2D5A"/>
+                </a:solidFill>
+              </a:rPr>
+              <a:t>Содержательные итоги</a:t>
+            </a:r>
+          </a:p>
+        </p:txBody>
+      </p:sp>
+      <p:sp>
+        <p:nvSpPr>
+          <p:cNvPr id="6" name="TextBox 5"/>
+          <p:cNvSpPr txBox="1"/>
+          <p:nvPr/>
+        </p:nvSpPr>
+        <p:spPr>
+          <a:xfrm>
+            <a:off x="548640" y="4480560"/>
+            <a:ext cx="11064240" cy="2194560"/>
+          </a:xfrm>
+          <a:prstGeom prst="rect">
+            <a:avLst/>
+          </a:prstGeom>
+          <a:noFill/>
+        </p:spPr>
+        <p:txBody>
+          <a:bodyPr wrap="square">
+            <a:spAutoFit/>
+          </a:bodyPr>
+          <a:lstStyle/>
+          <a:p>
+            <a:pPr>
+              <a:spcAft>
+                <a:spcPts val="600"/>
+              </a:spcAft>
+            </a:pPr>
+            <a:r>
+              <a:rPr sz="1400">
+                <a:solidFill>
+                  <a:srgbClr val="222222"/>
+                </a:solidFill>
+              </a:rPr>
+              <a:t>•  Рекуррентные модели (DKT) превосходят BKT на 0.08–0.09 AUC; разрыв соответствует литературе.</a:t>
+            </a:r>
+          </a:p>
+          <a:p>
+            <a:pPr>
+              <a:spcAft>
+                <a:spcPts val="600"/>
+              </a:spcAft>
+            </a:pPr>
+            <a:r>
+              <a:rPr sz="1400">
+                <a:solidFill>
+                  <a:srgbClr val="222222"/>
+                </a:solidFill>
+              </a:rPr>
+              <a:t>•  Автоматический подбор архитектуры (Optuna) даёт прирост +0.002 AUC и выбирает сильную регуляризацию.</a:t>
+            </a:r>
+          </a:p>
+          <a:p>
+            <a:pPr>
+              <a:spcAft>
+                <a:spcPts val="600"/>
+              </a:spcAft>
+            </a:pPr>
+            <a:r>
+              <a:rPr sz="1400">
+                <a:solidFill>
+                  <a:srgbClr val="222222"/>
+                </a:solidFill>
+              </a:rPr>
+              <a:t>•  AutoML на инженерных причинных признаках достигает AUC 0.7914 — на 0.010 ниже специализированной DKT.</a:t>
+            </a:r>
+          </a:p>
+          <a:p>
+            <a:pPr>
+              <a:spcAft>
+                <a:spcPts val="600"/>
+              </a:spcAft>
+            </a:pPr>
+            <a:r>
+              <a:rPr sz="1400">
+                <a:solidFill>
+                  <a:srgbClr val="222222"/>
+                </a:solidFill>
+              </a:rPr>
+              <a:t>•  Дрейфа между train и test не обнаружено; data-quality gate пройден.</a:t>
             </a:r>
           </a:p>
         </p:txBody>

</xml_diff>